<commit_message>
remove buisness model and condense slides
</commit_message>
<xml_diff>
--- a/Documentation/FinalPresentation/VulcanActivityTracker-Group2-Revised.pptx
+++ b/Documentation/FinalPresentation/VulcanActivityTracker-Group2-Revised.pptx
@@ -5,19 +5,18 @@
     <p:sldMasterId id="2147483648" r:id="rId1"/>
   </p:sldMasterIdLst>
   <p:notesMasterIdLst>
-    <p:notesMasterId r:id="rId9"/>
+    <p:notesMasterId r:id="rId8"/>
   </p:notesMasterIdLst>
   <p:handoutMasterIdLst>
-    <p:handoutMasterId r:id="rId10"/>
+    <p:handoutMasterId r:id="rId9"/>
   </p:handoutMasterIdLst>
   <p:sldIdLst>
     <p:sldId id="287" r:id="rId2"/>
     <p:sldId id="281" r:id="rId3"/>
     <p:sldId id="280" r:id="rId4"/>
     <p:sldId id="279" r:id="rId5"/>
-    <p:sldId id="275" r:id="rId6"/>
-    <p:sldId id="286" r:id="rId7"/>
-    <p:sldId id="278" r:id="rId8"/>
+    <p:sldId id="286" r:id="rId6"/>
+    <p:sldId id="278" r:id="rId7"/>
   </p:sldIdLst>
   <p:sldSz cx="12192000" cy="6858000"/>
   <p:notesSz cx="6858000" cy="9144000"/>
@@ -127,7 +126,7 @@
 <file path=ppt/revisionInfo.xml><?xml version="1.0" encoding="utf-8"?>
 <p1510:revInfo xmlns:a="http://schemas.openxmlformats.org/drawingml/2006/main" xmlns:r="http://schemas.openxmlformats.org/officeDocument/2006/relationships" xmlns:p1510="http://schemas.microsoft.com/office/powerpoint/2015/10/main">
   <p1510:revLst>
-    <p1510:client id="{7E171808-A062-4BC8-87AA-AF9D88B1042E}" v="84" dt="2026-04-27T14:45:51.819"/>
+    <p1510:client id="{7E171808-A062-4BC8-87AA-AF9D88B1042E}" v="89" dt="2026-04-27T20:58:27.052"/>
   </p1510:revLst>
 </p1510:revInfo>
 </file>
@@ -161,7 +160,7 @@
   <pc:docChgLst>
     <pc:chgData name="Margo Bonal" userId="18c9fa0f-b53d-478b-9dc0-6ad88786c19f" providerId="ADAL" clId="{93D479E5-F67F-4B8A-A78F-A0B574A116B6}"/>
     <pc:docChg chg="undo redo custSel addSld delSld modSld sldOrd addSection delSection">
-      <pc:chgData name="Margo Bonal" userId="18c9fa0f-b53d-478b-9dc0-6ad88786c19f" providerId="ADAL" clId="{93D479E5-F67F-4B8A-A78F-A0B574A116B6}" dt="2026-04-27T14:47:10.514" v="5131" actId="27636"/>
+      <pc:chgData name="Margo Bonal" userId="18c9fa0f-b53d-478b-9dc0-6ad88786c19f" providerId="ADAL" clId="{93D479E5-F67F-4B8A-A78F-A0B574A116B6}" dt="2026-04-27T20:58:42.197" v="5186" actId="20577"/>
       <pc:docMkLst>
         <pc:docMk/>
       </pc:docMkLst>
@@ -561,8 +560,8 @@
           <pc:sldMk cId="2561402868" sldId="264"/>
         </pc:sldMkLst>
       </pc:sldChg>
-      <pc:sldChg chg="addSp delSp modSp new mod ord setBg">
-        <pc:chgData name="Margo Bonal" userId="18c9fa0f-b53d-478b-9dc0-6ad88786c19f" providerId="ADAL" clId="{93D479E5-F67F-4B8A-A78F-A0B574A116B6}" dt="2026-04-26T17:04:28.640" v="4983" actId="2062"/>
+      <pc:sldChg chg="addSp delSp modSp new del mod ord setBg">
+        <pc:chgData name="Margo Bonal" userId="18c9fa0f-b53d-478b-9dc0-6ad88786c19f" providerId="ADAL" clId="{93D479E5-F67F-4B8A-A78F-A0B574A116B6}" dt="2026-04-27T20:57:40.784" v="5150" actId="2696"/>
         <pc:sldMkLst>
           <pc:docMk/>
           <pc:sldMk cId="606434410" sldId="275"/>
@@ -982,7 +981,7 @@
         </pc:cxnChg>
       </pc:sldChg>
       <pc:sldChg chg="addSp delSp modSp new mod ord setBg modNotesTx">
-        <pc:chgData name="Margo Bonal" userId="18c9fa0f-b53d-478b-9dc0-6ad88786c19f" providerId="ADAL" clId="{93D479E5-F67F-4B8A-A78F-A0B574A116B6}" dt="2026-04-27T14:47:10.514" v="5131" actId="27636"/>
+        <pc:chgData name="Margo Bonal" userId="18c9fa0f-b53d-478b-9dc0-6ad88786c19f" providerId="ADAL" clId="{93D479E5-F67F-4B8A-A78F-A0B574A116B6}" dt="2026-04-27T20:58:42.197" v="5186" actId="20577"/>
         <pc:sldMkLst>
           <pc:docMk/>
           <pc:sldMk cId="2582527457" sldId="281"/>
@@ -996,7 +995,7 @@
           </ac:spMkLst>
         </pc:spChg>
         <pc:spChg chg="add del mod">
-          <ac:chgData name="Margo Bonal" userId="18c9fa0f-b53d-478b-9dc0-6ad88786c19f" providerId="ADAL" clId="{93D479E5-F67F-4B8A-A78F-A0B574A116B6}" dt="2026-04-27T14:47:10.514" v="5131" actId="27636"/>
+          <ac:chgData name="Margo Bonal" userId="18c9fa0f-b53d-478b-9dc0-6ad88786c19f" providerId="ADAL" clId="{93D479E5-F67F-4B8A-A78F-A0B574A116B6}" dt="2026-04-27T20:58:42.197" v="5186" actId="20577"/>
           <ac:spMkLst>
             <pc:docMk/>
             <pc:sldMk cId="2582527457" sldId="281"/>
@@ -1037,13 +1036,13 @@
         </pc:cxnChg>
       </pc:sldChg>
       <pc:sldChg chg="modSp mod">
-        <pc:chgData name="Margo Bonal" userId="18c9fa0f-b53d-478b-9dc0-6ad88786c19f" providerId="ADAL" clId="{93D479E5-F67F-4B8A-A78F-A0B574A116B6}" dt="2026-04-26T17:04:36.069" v="4985" actId="12788"/>
+        <pc:chgData name="Margo Bonal" userId="18c9fa0f-b53d-478b-9dc0-6ad88786c19f" providerId="ADAL" clId="{93D479E5-F67F-4B8A-A78F-A0B574A116B6}" dt="2026-04-27T20:56:29.595" v="5149" actId="20577"/>
         <pc:sldMkLst>
           <pc:docMk/>
           <pc:sldMk cId="294120850" sldId="286"/>
         </pc:sldMkLst>
         <pc:spChg chg="mod">
-          <ac:chgData name="Margo Bonal" userId="18c9fa0f-b53d-478b-9dc0-6ad88786c19f" providerId="ADAL" clId="{93D479E5-F67F-4B8A-A78F-A0B574A116B6}" dt="2026-04-26T17:04:36.069" v="4985" actId="12788"/>
+          <ac:chgData name="Margo Bonal" userId="18c9fa0f-b53d-478b-9dc0-6ad88786c19f" providerId="ADAL" clId="{93D479E5-F67F-4B8A-A78F-A0B574A116B6}" dt="2026-04-27T20:56:29.595" v="5149" actId="20577"/>
           <ac:spMkLst>
             <pc:docMk/>
             <pc:sldMk cId="294120850" sldId="286"/>
@@ -6694,21 +6693,7 @@
                   <a:schemeClr val="tx1"/>
                 </a:solidFill>
               </a:rPr>
-              <a:t>Combines multiple fitness tools into one platform</a:t>
-            </a:r>
-          </a:p>
-          <a:p>
-            <a:pPr marL="171450" indent="-171450">
-              <a:buFont typeface="Arial" panose="020B0604020202020204" pitchFamily="34" charset="0"/>
-              <a:buChar char="•"/>
-            </a:pPr>
-            <a:r>
-              <a:rPr lang="en-US" sz="2000" dirty="0">
-                <a:solidFill>
-                  <a:schemeClr val="tx1"/>
-                </a:solidFill>
-              </a:rPr>
-              <a:t>Connect with friends to build a fitness community</a:t>
+              <a:t>Combines multiple fitness tools and social community</a:t>
             </a:r>
           </a:p>
           <a:p>
@@ -9389,947 +9374,6 @@
   <p:cSld>
     <p:bg>
       <p:bgPr>
-        <a:gradFill>
-          <a:gsLst>
-            <a:gs pos="0">
-              <a:schemeClr val="accent1">
-                <a:lumMod val="5000"/>
-                <a:lumOff val="95000"/>
-              </a:schemeClr>
-            </a:gs>
-            <a:gs pos="74000">
-              <a:schemeClr val="accent1">
-                <a:lumMod val="45000"/>
-                <a:lumOff val="55000"/>
-              </a:schemeClr>
-            </a:gs>
-            <a:gs pos="83000">
-              <a:schemeClr val="accent1">
-                <a:lumMod val="45000"/>
-                <a:lumOff val="55000"/>
-              </a:schemeClr>
-            </a:gs>
-            <a:gs pos="100000">
-              <a:schemeClr val="accent1">
-                <a:lumMod val="30000"/>
-                <a:lumOff val="70000"/>
-              </a:schemeClr>
-            </a:gs>
-          </a:gsLst>
-          <a:lin ang="5400000" scaled="1"/>
-        </a:gradFill>
-        <a:effectLst/>
-      </p:bgPr>
-    </p:bg>
-    <p:spTree>
-      <p:nvGrpSpPr>
-        <p:cNvPr id="1" name=""/>
-        <p:cNvGrpSpPr/>
-        <p:nvPr/>
-      </p:nvGrpSpPr>
-      <p:grpSpPr>
-        <a:xfrm>
-          <a:off x="0" y="0"/>
-          <a:ext cx="0" cy="0"/>
-          <a:chOff x="0" y="0"/>
-          <a:chExt cx="0" cy="0"/>
-        </a:xfrm>
-      </p:grpSpPr>
-      <p:sp>
-        <p:nvSpPr>
-          <p:cNvPr id="20" name="Rectangle 19">
-            <a:extLst>
-              <a:ext uri="{FF2B5EF4-FFF2-40B4-BE49-F238E27FC236}">
-                <a16:creationId xmlns:a16="http://schemas.microsoft.com/office/drawing/2014/main" id="{AE2B703B-46F9-481A-A605-82E2A828C4FA}"/>
-              </a:ext>
-              <a:ext uri="{C183D7F6-B498-43B3-948B-1728B52AA6E4}">
-                <adec:decorative xmlns:adec="http://schemas.microsoft.com/office/drawing/2017/decorative" val="1"/>
-              </a:ext>
-            </a:extLst>
-          </p:cNvPr>
-          <p:cNvSpPr>
-            <a:spLocks noGrp="1" noRot="1" noChangeAspect="1" noMove="1" noResize="1" noEditPoints="1" noAdjustHandles="1" noChangeArrowheads="1" noChangeShapeType="1" noTextEdit="1"/>
-          </p:cNvSpPr>
-          <p:nvPr>
-            <p:extLst>
-              <p:ext uri="{386F3935-93C4-4BCD-93E2-E3B085C9AB24}">
-                <p16:designElem xmlns:p16="http://schemas.microsoft.com/office/powerpoint/2015/main" val="1"/>
-              </p:ext>
-            </p:extLst>
-          </p:nvPr>
-        </p:nvSpPr>
-        <p:spPr>
-          <a:xfrm>
-            <a:off x="0" y="0"/>
-            <a:ext cx="12192000" cy="6858000"/>
-          </a:xfrm>
-          <a:prstGeom prst="rect">
-            <a:avLst/>
-          </a:prstGeom>
-          <a:solidFill>
-            <a:schemeClr val="accent2"/>
-          </a:solidFill>
-          <a:ln>
-            <a:noFill/>
-          </a:ln>
-        </p:spPr>
-        <p:style>
-          <a:lnRef idx="2">
-            <a:schemeClr val="accent1">
-              <a:shade val="50000"/>
-            </a:schemeClr>
-          </a:lnRef>
-          <a:fillRef idx="1">
-            <a:schemeClr val="accent1"/>
-          </a:fillRef>
-          <a:effectRef idx="0">
-            <a:schemeClr val="accent1"/>
-          </a:effectRef>
-          <a:fontRef idx="minor">
-            <a:schemeClr val="lt1"/>
-          </a:fontRef>
-        </p:style>
-        <p:txBody>
-          <a:bodyPr rtlCol="0" anchor="ctr"/>
-          <a:lstStyle/>
-          <a:p>
-            <a:pPr algn="ctr"/>
-            <a:endParaRPr lang="en-US"/>
-          </a:p>
-        </p:txBody>
-      </p:sp>
-      <p:sp>
-        <p:nvSpPr>
-          <p:cNvPr id="2" name="Title 1">
-            <a:extLst>
-              <a:ext uri="{FF2B5EF4-FFF2-40B4-BE49-F238E27FC236}">
-                <a16:creationId xmlns:a16="http://schemas.microsoft.com/office/drawing/2014/main" id="{D6C076D5-0B0F-A0A5-DAB4-A94391E22A71}"/>
-              </a:ext>
-            </a:extLst>
-          </p:cNvPr>
-          <p:cNvSpPr>
-            <a:spLocks noGrp="1"/>
-          </p:cNvSpPr>
-          <p:nvPr>
-            <p:ph type="title"/>
-          </p:nvPr>
-        </p:nvSpPr>
-        <p:spPr>
-          <a:xfrm>
-            <a:off x="1001702" y="291688"/>
-            <a:ext cx="10515600" cy="1004594"/>
-          </a:xfrm>
-          <a:solidFill>
-            <a:schemeClr val="accent2"/>
-          </a:solidFill>
-        </p:spPr>
-        <p:txBody>
-          <a:bodyPr>
-            <a:normAutofit/>
-          </a:bodyPr>
-          <a:lstStyle/>
-          <a:p>
-            <a:pPr algn="ctr"/>
-            <a:r>
-              <a:rPr lang="en-US" dirty="0">
-                <a:solidFill>
-                  <a:srgbClr val="FFFFFF"/>
-                </a:solidFill>
-              </a:rPr>
-              <a:t>Business Model </a:t>
-            </a:r>
-          </a:p>
-        </p:txBody>
-      </p:sp>
-      <p:sp>
-        <p:nvSpPr>
-          <p:cNvPr id="22" name="Rectangle: Rounded Corners 21">
-            <a:extLst>
-              <a:ext uri="{FF2B5EF4-FFF2-40B4-BE49-F238E27FC236}">
-                <a16:creationId xmlns:a16="http://schemas.microsoft.com/office/drawing/2014/main" id="{F13BE4D7-0C3D-4906-B230-A1C5B4665CCF}"/>
-              </a:ext>
-              <a:ext uri="{C183D7F6-B498-43B3-948B-1728B52AA6E4}">
-                <adec:decorative xmlns:adec="http://schemas.microsoft.com/office/drawing/2017/decorative" val="1"/>
-              </a:ext>
-            </a:extLst>
-          </p:cNvPr>
-          <p:cNvSpPr>
-            <a:spLocks noGrp="1" noRot="1" noChangeAspect="1" noMove="1" noResize="1" noEditPoints="1" noAdjustHandles="1" noChangeArrowheads="1" noChangeShapeType="1" noTextEdit="1"/>
-          </p:cNvSpPr>
-          <p:nvPr>
-            <p:extLst>
-              <p:ext uri="{386F3935-93C4-4BCD-93E2-E3B085C9AB24}">
-                <p16:designElem xmlns:p16="http://schemas.microsoft.com/office/powerpoint/2015/main" val="1"/>
-              </p:ext>
-            </p:extLst>
-          </p:nvPr>
-        </p:nvSpPr>
-        <p:spPr>
-          <a:xfrm>
-            <a:off x="579496" y="1587970"/>
-            <a:ext cx="11033008" cy="4768380"/>
-          </a:xfrm>
-          <a:prstGeom prst="roundRect">
-            <a:avLst>
-              <a:gd name="adj" fmla="val 3174"/>
-            </a:avLst>
-          </a:prstGeom>
-          <a:solidFill>
-            <a:schemeClr val="bg1">
-              <a:alpha val="95000"/>
-            </a:schemeClr>
-          </a:solidFill>
-          <a:ln>
-            <a:noFill/>
-          </a:ln>
-        </p:spPr>
-        <p:style>
-          <a:lnRef idx="2">
-            <a:schemeClr val="accent1">
-              <a:shade val="50000"/>
-            </a:schemeClr>
-          </a:lnRef>
-          <a:fillRef idx="1">
-            <a:schemeClr val="accent1"/>
-          </a:fillRef>
-          <a:effectRef idx="0">
-            <a:schemeClr val="accent1"/>
-          </a:effectRef>
-          <a:fontRef idx="minor">
-            <a:schemeClr val="lt1"/>
-          </a:fontRef>
-        </p:style>
-        <p:txBody>
-          <a:bodyPr rtlCol="0" anchor="ctr"/>
-          <a:lstStyle/>
-          <a:p>
-            <a:pPr algn="ctr"/>
-            <a:endParaRPr lang="en-US"/>
-          </a:p>
-        </p:txBody>
-      </p:sp>
-      <p:sp>
-        <p:nvSpPr>
-          <p:cNvPr id="3" name="TextBox 2">
-            <a:extLst>
-              <a:ext uri="{FF2B5EF4-FFF2-40B4-BE49-F238E27FC236}">
-                <a16:creationId xmlns:a16="http://schemas.microsoft.com/office/drawing/2014/main" id="{5BA1FDAB-BF64-1FC7-8CE6-75537E5CD8D5}"/>
-              </a:ext>
-            </a:extLst>
-          </p:cNvPr>
-          <p:cNvSpPr txBox="1"/>
-          <p:nvPr/>
-        </p:nvSpPr>
-        <p:spPr>
-          <a:xfrm>
-            <a:off x="3955284" y="1929650"/>
-            <a:ext cx="4752163" cy="646331"/>
-          </a:xfrm>
-          <a:prstGeom prst="rect">
-            <a:avLst/>
-          </a:prstGeom>
-          <a:noFill/>
-        </p:spPr>
-        <p:txBody>
-          <a:bodyPr wrap="square" rtlCol="0">
-            <a:spAutoFit/>
-          </a:bodyPr>
-          <a:lstStyle/>
-          <a:p>
-            <a:pPr algn="ctr"/>
-            <a:r>
-              <a:rPr lang="en-US" dirty="0"/>
-              <a:t>Estimated Production for 100 users/month:</a:t>
-            </a:r>
-          </a:p>
-          <a:p>
-            <a:endParaRPr lang="en-US" dirty="0"/>
-          </a:p>
-        </p:txBody>
-      </p:sp>
-      <p:graphicFrame>
-        <p:nvGraphicFramePr>
-          <p:cNvPr id="6" name="Table 5">
-            <a:extLst>
-              <a:ext uri="{FF2B5EF4-FFF2-40B4-BE49-F238E27FC236}">
-                <a16:creationId xmlns:a16="http://schemas.microsoft.com/office/drawing/2014/main" id="{27EACA2E-750E-36F7-A7AE-14DB1D64E678}"/>
-              </a:ext>
-            </a:extLst>
-          </p:cNvPr>
-          <p:cNvGraphicFramePr>
-            <a:graphicFrameLocks noGrp="1"/>
-          </p:cNvGraphicFramePr>
-          <p:nvPr>
-            <p:extLst>
-              <p:ext uri="{D42A27DB-BD31-4B8C-83A1-F6EECF244321}">
-                <p14:modId xmlns:p14="http://schemas.microsoft.com/office/powerpoint/2010/main" val="1753972458"/>
-              </p:ext>
-            </p:extLst>
-          </p:nvPr>
-        </p:nvGraphicFramePr>
-        <p:xfrm>
-          <a:off x="2195502" y="3044990"/>
-          <a:ext cx="8128000" cy="2956560"/>
-        </p:xfrm>
-        <a:graphic>
-          <a:graphicData uri="http://schemas.openxmlformats.org/drawingml/2006/table">
-            <a:tbl>
-              <a:tblPr firstRow="1" bandRow="1">
-                <a:tableStyleId>{5C22544A-7EE6-4342-B048-85BDC9FD1C3A}</a:tableStyleId>
-              </a:tblPr>
-              <a:tblGrid>
-                <a:gridCol w="4064000">
-                  <a:extLst>
-                    <a:ext uri="{9D8B030D-6E8A-4147-A177-3AD203B41FA5}">
-                      <a16:colId xmlns:a16="http://schemas.microsoft.com/office/drawing/2014/main" val="1095417402"/>
-                    </a:ext>
-                  </a:extLst>
-                </a:gridCol>
-                <a:gridCol w="4064000">
-                  <a:extLst>
-                    <a:ext uri="{9D8B030D-6E8A-4147-A177-3AD203B41FA5}">
-                      <a16:colId xmlns:a16="http://schemas.microsoft.com/office/drawing/2014/main" val="2844060281"/>
-                    </a:ext>
-                  </a:extLst>
-                </a:gridCol>
-              </a:tblGrid>
-              <a:tr h="370840">
-                <a:tc>
-                  <a:txBody>
-                    <a:bodyPr/>
-                    <a:lstStyle/>
-                    <a:p>
-                      <a:endParaRPr lang="en-US" dirty="0"/>
-                    </a:p>
-                  </a:txBody>
-                  <a:tcPr>
-                    <a:lnL w="12700" cap="flat" cmpd="sng" algn="ctr">
-                      <a:solidFill>
-                        <a:schemeClr val="tx1"/>
-                      </a:solidFill>
-                      <a:prstDash val="solid"/>
-                      <a:round/>
-                      <a:headEnd type="none" w="med" len="med"/>
-                      <a:tailEnd type="none" w="med" len="med"/>
-                    </a:lnL>
-                    <a:lnT w="12700" cap="flat" cmpd="sng" algn="ctr">
-                      <a:solidFill>
-                        <a:schemeClr val="tx1"/>
-                      </a:solidFill>
-                      <a:prstDash val="solid"/>
-                      <a:round/>
-                      <a:headEnd type="none" w="med" len="med"/>
-                      <a:tailEnd type="none" w="med" len="med"/>
-                    </a:lnT>
-                  </a:tcPr>
-                </a:tc>
-                <a:tc>
-                  <a:txBody>
-                    <a:bodyPr/>
-                    <a:lstStyle/>
-                    <a:p>
-                      <a:endParaRPr lang="en-US" dirty="0"/>
-                    </a:p>
-                  </a:txBody>
-                  <a:tcPr>
-                    <a:lnR w="12700" cap="flat" cmpd="sng" algn="ctr">
-                      <a:solidFill>
-                        <a:schemeClr val="tx1"/>
-                      </a:solidFill>
-                      <a:prstDash val="solid"/>
-                      <a:round/>
-                      <a:headEnd type="none" w="med" len="med"/>
-                      <a:tailEnd type="none" w="med" len="med"/>
-                    </a:lnR>
-                    <a:lnT w="12700" cap="flat" cmpd="sng" algn="ctr">
-                      <a:solidFill>
-                        <a:schemeClr val="tx1"/>
-                      </a:solidFill>
-                      <a:prstDash val="solid"/>
-                      <a:round/>
-                      <a:headEnd type="none" w="med" len="med"/>
-                      <a:tailEnd type="none" w="med" len="med"/>
-                    </a:lnT>
-                  </a:tcPr>
-                </a:tc>
-                <a:extLst>
-                  <a:ext uri="{0D108BD9-81ED-4DB2-BD59-A6C34878D82A}">
-                    <a16:rowId xmlns:a16="http://schemas.microsoft.com/office/drawing/2014/main" val="1191493328"/>
-                  </a:ext>
-                </a:extLst>
-              </a:tr>
-              <a:tr h="370840">
-                <a:tc>
-                  <a:txBody>
-                    <a:bodyPr/>
-                    <a:lstStyle/>
-                    <a:p>
-                      <a:pPr algn="l"/>
-                      <a:r>
-                        <a:rPr lang="en-US" dirty="0"/>
-                        <a:t>Microsoft Azure SQL Server</a:t>
-                      </a:r>
-                    </a:p>
-                  </a:txBody>
-                  <a:tcPr>
-                    <a:lnL w="12700" cap="flat" cmpd="sng" algn="ctr">
-                      <a:solidFill>
-                        <a:schemeClr val="tx1"/>
-                      </a:solidFill>
-                      <a:prstDash val="solid"/>
-                      <a:round/>
-                      <a:headEnd type="none" w="med" len="med"/>
-                      <a:tailEnd type="none" w="med" len="med"/>
-                    </a:lnL>
-                  </a:tcPr>
-                </a:tc>
-                <a:tc>
-                  <a:txBody>
-                    <a:bodyPr/>
-                    <a:lstStyle/>
-                    <a:p>
-                      <a:pPr>
-                        <a:buNone/>
-                      </a:pPr>
-                      <a:r>
-                        <a:rPr lang="en-US" dirty="0"/>
-                        <a:t>$7 – $15</a:t>
-                      </a:r>
-                    </a:p>
-                  </a:txBody>
-                  <a:tcPr anchor="ctr">
-                    <a:lnR w="12700" cap="flat" cmpd="sng" algn="ctr">
-                      <a:solidFill>
-                        <a:schemeClr val="tx1"/>
-                      </a:solidFill>
-                      <a:prstDash val="solid"/>
-                      <a:round/>
-                      <a:headEnd type="none" w="med" len="med"/>
-                      <a:tailEnd type="none" w="med" len="med"/>
-                    </a:lnR>
-                  </a:tcPr>
-                </a:tc>
-                <a:extLst>
-                  <a:ext uri="{0D108BD9-81ED-4DB2-BD59-A6C34878D82A}">
-                    <a16:rowId xmlns:a16="http://schemas.microsoft.com/office/drawing/2014/main" val="2913341914"/>
-                  </a:ext>
-                </a:extLst>
-              </a:tr>
-              <a:tr h="370840">
-                <a:tc>
-                  <a:txBody>
-                    <a:bodyPr/>
-                    <a:lstStyle/>
-                    <a:p>
-                      <a:pPr marL="0" marR="0" lvl="0" indent="0" algn="l" defTabSz="914400" rtl="0" eaLnBrk="1" fontAlgn="auto" latinLnBrk="0" hangingPunct="1">
-                        <a:lnSpc>
-                          <a:spcPct val="100000"/>
-                        </a:lnSpc>
-                        <a:spcBef>
-                          <a:spcPts val="0"/>
-                        </a:spcBef>
-                        <a:spcAft>
-                          <a:spcPts val="0"/>
-                        </a:spcAft>
-                        <a:buClrTx/>
-                        <a:buSzTx/>
-                        <a:buFontTx/>
-                        <a:buNone/>
-                        <a:tabLst/>
-                        <a:defRPr/>
-                      </a:pPr>
-                      <a:r>
-                        <a:rPr lang="en-US" dirty="0"/>
-                        <a:t>Azure Database</a:t>
-                      </a:r>
-                    </a:p>
-                  </a:txBody>
-                  <a:tcPr>
-                    <a:lnL w="12700" cap="flat" cmpd="sng" algn="ctr">
-                      <a:solidFill>
-                        <a:schemeClr val="tx1"/>
-                      </a:solidFill>
-                      <a:prstDash val="solid"/>
-                      <a:round/>
-                      <a:headEnd type="none" w="med" len="med"/>
-                      <a:tailEnd type="none" w="med" len="med"/>
-                    </a:lnL>
-                  </a:tcPr>
-                </a:tc>
-                <a:tc>
-                  <a:txBody>
-                    <a:bodyPr/>
-                    <a:lstStyle/>
-                    <a:p>
-                      <a:r>
-                        <a:rPr lang="en-US" dirty="0"/>
-                        <a:t>$7 – $20</a:t>
-                      </a:r>
-                    </a:p>
-                  </a:txBody>
-                  <a:tcPr>
-                    <a:lnR w="12700" cap="flat" cmpd="sng" algn="ctr">
-                      <a:solidFill>
-                        <a:schemeClr val="tx1"/>
-                      </a:solidFill>
-                      <a:prstDash val="solid"/>
-                      <a:round/>
-                      <a:headEnd type="none" w="med" len="med"/>
-                      <a:tailEnd type="none" w="med" len="med"/>
-                    </a:lnR>
-                  </a:tcPr>
-                </a:tc>
-                <a:extLst>
-                  <a:ext uri="{0D108BD9-81ED-4DB2-BD59-A6C34878D82A}">
-                    <a16:rowId xmlns:a16="http://schemas.microsoft.com/office/drawing/2014/main" val="2554711460"/>
-                  </a:ext>
-                </a:extLst>
-              </a:tr>
-              <a:tr h="370840">
-                <a:tc>
-                  <a:txBody>
-                    <a:bodyPr/>
-                    <a:lstStyle/>
-                    <a:p>
-                      <a:pPr marL="0" marR="0" lvl="0" indent="0" algn="l" defTabSz="914400" rtl="0" eaLnBrk="1" fontAlgn="auto" latinLnBrk="0" hangingPunct="1">
-                        <a:lnSpc>
-                          <a:spcPct val="100000"/>
-                        </a:lnSpc>
-                        <a:spcBef>
-                          <a:spcPts val="0"/>
-                        </a:spcBef>
-                        <a:spcAft>
-                          <a:spcPts val="0"/>
-                        </a:spcAft>
-                        <a:buClrTx/>
-                        <a:buSzTx/>
-                        <a:buFontTx/>
-                        <a:buNone/>
-                        <a:tabLst/>
-                        <a:defRPr/>
-                      </a:pPr>
-                      <a:r>
-                        <a:rPr lang="en-US" dirty="0"/>
-                        <a:t>Render Hosting</a:t>
-                      </a:r>
-                    </a:p>
-                  </a:txBody>
-                  <a:tcPr>
-                    <a:lnL w="12700" cap="flat" cmpd="sng" algn="ctr">
-                      <a:solidFill>
-                        <a:schemeClr val="tx1"/>
-                      </a:solidFill>
-                      <a:prstDash val="solid"/>
-                      <a:round/>
-                      <a:headEnd type="none" w="med" len="med"/>
-                      <a:tailEnd type="none" w="med" len="med"/>
-                    </a:lnL>
-                  </a:tcPr>
-                </a:tc>
-                <a:tc>
-                  <a:txBody>
-                    <a:bodyPr/>
-                    <a:lstStyle/>
-                    <a:p>
-                      <a:pPr marL="0" marR="0" lvl="0" indent="0" algn="l" defTabSz="914400" rtl="0" eaLnBrk="1" fontAlgn="auto" latinLnBrk="0" hangingPunct="1">
-                        <a:lnSpc>
-                          <a:spcPct val="100000"/>
-                        </a:lnSpc>
-                        <a:spcBef>
-                          <a:spcPts val="0"/>
-                        </a:spcBef>
-                        <a:spcAft>
-                          <a:spcPts val="0"/>
-                        </a:spcAft>
-                        <a:buClrTx/>
-                        <a:buSzTx/>
-                        <a:buFontTx/>
-                        <a:buNone/>
-                        <a:tabLst/>
-                        <a:defRPr/>
-                      </a:pPr>
-                      <a:r>
-                        <a:rPr lang="en-US" dirty="0"/>
-                        <a:t>$7 – $15</a:t>
-                      </a:r>
-                    </a:p>
-                  </a:txBody>
-                  <a:tcPr>
-                    <a:lnR w="12700" cap="flat" cmpd="sng" algn="ctr">
-                      <a:solidFill>
-                        <a:schemeClr val="tx1"/>
-                      </a:solidFill>
-                      <a:prstDash val="solid"/>
-                      <a:round/>
-                      <a:headEnd type="none" w="med" len="med"/>
-                      <a:tailEnd type="none" w="med" len="med"/>
-                    </a:lnR>
-                  </a:tcPr>
-                </a:tc>
-                <a:extLst>
-                  <a:ext uri="{0D108BD9-81ED-4DB2-BD59-A6C34878D82A}">
-                    <a16:rowId xmlns:a16="http://schemas.microsoft.com/office/drawing/2014/main" val="2623904690"/>
-                  </a:ext>
-                </a:extLst>
-              </a:tr>
-              <a:tr h="370840">
-                <a:tc>
-                  <a:txBody>
-                    <a:bodyPr/>
-                    <a:lstStyle/>
-                    <a:p>
-                      <a:pPr marL="0" marR="0" lvl="0" indent="0" algn="l" defTabSz="914400" rtl="0" eaLnBrk="1" fontAlgn="auto" latinLnBrk="0" hangingPunct="1">
-                        <a:lnSpc>
-                          <a:spcPct val="100000"/>
-                        </a:lnSpc>
-                        <a:spcBef>
-                          <a:spcPts val="0"/>
-                        </a:spcBef>
-                        <a:spcAft>
-                          <a:spcPts val="0"/>
-                        </a:spcAft>
-                        <a:buClrTx/>
-                        <a:buSzTx/>
-                        <a:buFontTx/>
-                        <a:buNone/>
-                        <a:tabLst/>
-                        <a:defRPr/>
-                      </a:pPr>
-                      <a:r>
-                        <a:rPr lang="en-US" dirty="0"/>
-                        <a:t>Domain:</a:t>
-                      </a:r>
-                    </a:p>
-                  </a:txBody>
-                  <a:tcPr>
-                    <a:lnL w="12700" cap="flat" cmpd="sng" algn="ctr">
-                      <a:solidFill>
-                        <a:schemeClr val="tx1"/>
-                      </a:solidFill>
-                      <a:prstDash val="solid"/>
-                      <a:round/>
-                      <a:headEnd type="none" w="med" len="med"/>
-                      <a:tailEnd type="none" w="med" len="med"/>
-                    </a:lnL>
-                  </a:tcPr>
-                </a:tc>
-                <a:tc>
-                  <a:txBody>
-                    <a:bodyPr/>
-                    <a:lstStyle/>
-                    <a:p>
-                      <a:pPr>
-                        <a:buNone/>
-                      </a:pPr>
-                      <a:r>
-                        <a:rPr lang="en-US" dirty="0"/>
-                        <a:t>~$1</a:t>
-                      </a:r>
-                    </a:p>
-                  </a:txBody>
-                  <a:tcPr anchor="ctr">
-                    <a:lnR w="12700" cap="flat" cmpd="sng" algn="ctr">
-                      <a:solidFill>
-                        <a:schemeClr val="tx1"/>
-                      </a:solidFill>
-                      <a:prstDash val="solid"/>
-                      <a:round/>
-                      <a:headEnd type="none" w="med" len="med"/>
-                      <a:tailEnd type="none" w="med" len="med"/>
-                    </a:lnR>
-                  </a:tcPr>
-                </a:tc>
-                <a:extLst>
-                  <a:ext uri="{0D108BD9-81ED-4DB2-BD59-A6C34878D82A}">
-                    <a16:rowId xmlns:a16="http://schemas.microsoft.com/office/drawing/2014/main" val="1183009989"/>
-                  </a:ext>
-                </a:extLst>
-              </a:tr>
-              <a:tr h="0">
-                <a:tc>
-                  <a:txBody>
-                    <a:bodyPr/>
-                    <a:lstStyle/>
-                    <a:p>
-                      <a:pPr marL="0" marR="0" lvl="0" indent="0" algn="l" defTabSz="914400" rtl="0" eaLnBrk="1" fontAlgn="auto" latinLnBrk="0" hangingPunct="1">
-                        <a:lnSpc>
-                          <a:spcPct val="100000"/>
-                        </a:lnSpc>
-                        <a:spcBef>
-                          <a:spcPts val="0"/>
-                        </a:spcBef>
-                        <a:spcAft>
-                          <a:spcPts val="0"/>
-                        </a:spcAft>
-                        <a:buClrTx/>
-                        <a:buSzTx/>
-                        <a:buFontTx/>
-                        <a:buNone/>
-                        <a:tabLst/>
-                        <a:defRPr/>
-                      </a:pPr>
-                      <a:r>
-                        <a:rPr lang="en-US" dirty="0"/>
-                        <a:t>Monthly Maintenance: </a:t>
-                      </a:r>
-                    </a:p>
-                  </a:txBody>
-                  <a:tcPr>
-                    <a:lnL w="12700" cap="flat" cmpd="sng" algn="ctr">
-                      <a:solidFill>
-                        <a:schemeClr val="tx1"/>
-                      </a:solidFill>
-                      <a:prstDash val="solid"/>
-                      <a:round/>
-                      <a:headEnd type="none" w="med" len="med"/>
-                      <a:tailEnd type="none" w="med" len="med"/>
-                    </a:lnL>
-                  </a:tcPr>
-                </a:tc>
-                <a:tc>
-                  <a:txBody>
-                    <a:bodyPr/>
-                    <a:lstStyle/>
-                    <a:p>
-                      <a:pPr>
-                        <a:buNone/>
-                      </a:pPr>
-                      <a:r>
-                        <a:rPr lang="en-US" dirty="0"/>
-                        <a:t>$5 – $10</a:t>
-                      </a:r>
-                    </a:p>
-                  </a:txBody>
-                  <a:tcPr anchor="ctr">
-                    <a:lnR w="12700" cap="flat" cmpd="sng" algn="ctr">
-                      <a:solidFill>
-                        <a:schemeClr val="tx1"/>
-                      </a:solidFill>
-                      <a:prstDash val="solid"/>
-                      <a:round/>
-                      <a:headEnd type="none" w="med" len="med"/>
-                      <a:tailEnd type="none" w="med" len="med"/>
-                    </a:lnR>
-                  </a:tcPr>
-                </a:tc>
-                <a:extLst>
-                  <a:ext uri="{0D108BD9-81ED-4DB2-BD59-A6C34878D82A}">
-                    <a16:rowId xmlns:a16="http://schemas.microsoft.com/office/drawing/2014/main" val="1963185262"/>
-                  </a:ext>
-                </a:extLst>
-              </a:tr>
-              <a:tr h="0">
-                <a:tc>
-                  <a:txBody>
-                    <a:bodyPr/>
-                    <a:lstStyle/>
-                    <a:p>
-                      <a:pPr marL="0" marR="0" lvl="0" indent="0" algn="l" defTabSz="914400" rtl="0" eaLnBrk="1" fontAlgn="auto" latinLnBrk="0" hangingPunct="1">
-                        <a:lnSpc>
-                          <a:spcPct val="100000"/>
-                        </a:lnSpc>
-                        <a:spcBef>
-                          <a:spcPts val="0"/>
-                        </a:spcBef>
-                        <a:spcAft>
-                          <a:spcPts val="0"/>
-                        </a:spcAft>
-                        <a:buClrTx/>
-                        <a:buSzTx/>
-                        <a:buFontTx/>
-                        <a:buNone/>
-                        <a:tabLst/>
-                        <a:defRPr/>
-                      </a:pPr>
-                      <a:r>
-                        <a:rPr lang="en-US" dirty="0"/>
-                        <a:t>MailerSend Starter Subscription</a:t>
-                      </a:r>
-                    </a:p>
-                  </a:txBody>
-                  <a:tcPr>
-                    <a:lnL w="12700" cap="flat" cmpd="sng" algn="ctr">
-                      <a:solidFill>
-                        <a:schemeClr val="tx1"/>
-                      </a:solidFill>
-                      <a:prstDash val="solid"/>
-                      <a:round/>
-                      <a:headEnd type="none" w="med" len="med"/>
-                      <a:tailEnd type="none" w="med" len="med"/>
-                    </a:lnL>
-                  </a:tcPr>
-                </a:tc>
-                <a:tc>
-                  <a:txBody>
-                    <a:bodyPr/>
-                    <a:lstStyle/>
-                    <a:p>
-                      <a:pPr>
-                        <a:buNone/>
-                      </a:pPr>
-                      <a:r>
-                        <a:rPr lang="en-US" dirty="0"/>
-                        <a:t>$28</a:t>
-                      </a:r>
-                    </a:p>
-                  </a:txBody>
-                  <a:tcPr anchor="ctr">
-                    <a:lnR w="12700" cap="flat" cmpd="sng" algn="ctr">
-                      <a:solidFill>
-                        <a:schemeClr val="tx1"/>
-                      </a:solidFill>
-                      <a:prstDash val="solid"/>
-                      <a:round/>
-                      <a:headEnd type="none" w="med" len="med"/>
-                      <a:tailEnd type="none" w="med" len="med"/>
-                    </a:lnR>
-                  </a:tcPr>
-                </a:tc>
-                <a:extLst>
-                  <a:ext uri="{0D108BD9-81ED-4DB2-BD59-A6C34878D82A}">
-                    <a16:rowId xmlns:a16="http://schemas.microsoft.com/office/drawing/2014/main" val="2062421038"/>
-                  </a:ext>
-                </a:extLst>
-              </a:tr>
-              <a:tr h="370840">
-                <a:tc>
-                  <a:txBody>
-                    <a:bodyPr/>
-                    <a:lstStyle/>
-                    <a:p>
-                      <a:pPr marL="0" marR="0" lvl="0" indent="0" algn="l" defTabSz="914400" rtl="0" eaLnBrk="1" fontAlgn="auto" latinLnBrk="0" hangingPunct="1">
-                        <a:lnSpc>
-                          <a:spcPct val="100000"/>
-                        </a:lnSpc>
-                        <a:spcBef>
-                          <a:spcPts val="0"/>
-                        </a:spcBef>
-                        <a:spcAft>
-                          <a:spcPts val="0"/>
-                        </a:spcAft>
-                        <a:buClrTx/>
-                        <a:buSzTx/>
-                        <a:buFontTx/>
-                        <a:buNone/>
-                        <a:tabLst/>
-                        <a:defRPr/>
-                      </a:pPr>
-                      <a:r>
-                        <a:rPr lang="en-US" dirty="0"/>
-                        <a:t>Total:</a:t>
-                      </a:r>
-                    </a:p>
-                  </a:txBody>
-                  <a:tcPr>
-                    <a:lnL w="12700" cap="flat" cmpd="sng" algn="ctr">
-                      <a:solidFill>
-                        <a:schemeClr val="tx1"/>
-                      </a:solidFill>
-                      <a:prstDash val="solid"/>
-                      <a:round/>
-                      <a:headEnd type="none" w="med" len="med"/>
-                      <a:tailEnd type="none" w="med" len="med"/>
-                    </a:lnL>
-                    <a:lnB w="12700" cap="flat" cmpd="sng" algn="ctr">
-                      <a:solidFill>
-                        <a:schemeClr val="tx1"/>
-                      </a:solidFill>
-                      <a:prstDash val="solid"/>
-                      <a:round/>
-                      <a:headEnd type="none" w="med" len="med"/>
-                      <a:tailEnd type="none" w="med" len="med"/>
-                    </a:lnB>
-                  </a:tcPr>
-                </a:tc>
-                <a:tc>
-                  <a:txBody>
-                    <a:bodyPr/>
-                    <a:lstStyle/>
-                    <a:p>
-                      <a:r>
-                        <a:rPr lang="en-US" dirty="0"/>
-                        <a:t>$55 – $89</a:t>
-                      </a:r>
-                    </a:p>
-                  </a:txBody>
-                  <a:tcPr>
-                    <a:lnR w="12700" cap="flat" cmpd="sng" algn="ctr">
-                      <a:solidFill>
-                        <a:schemeClr val="tx1"/>
-                      </a:solidFill>
-                      <a:prstDash val="solid"/>
-                      <a:round/>
-                      <a:headEnd type="none" w="med" len="med"/>
-                      <a:tailEnd type="none" w="med" len="med"/>
-                    </a:lnR>
-                    <a:lnB w="12700" cap="flat" cmpd="sng" algn="ctr">
-                      <a:solidFill>
-                        <a:schemeClr val="tx1"/>
-                      </a:solidFill>
-                      <a:prstDash val="solid"/>
-                      <a:round/>
-                      <a:headEnd type="none" w="med" len="med"/>
-                      <a:tailEnd type="none" w="med" len="med"/>
-                    </a:lnB>
-                  </a:tcPr>
-                </a:tc>
-                <a:extLst>
-                  <a:ext uri="{0D108BD9-81ED-4DB2-BD59-A6C34878D82A}">
-                    <a16:rowId xmlns:a16="http://schemas.microsoft.com/office/drawing/2014/main" val="2053192884"/>
-                  </a:ext>
-                </a:extLst>
-              </a:tr>
-            </a:tbl>
-          </a:graphicData>
-        </a:graphic>
-      </p:graphicFrame>
-      <p:sp>
-        <p:nvSpPr>
-          <p:cNvPr id="4" name="Slide Number Placeholder 3">
-            <a:extLst>
-              <a:ext uri="{FF2B5EF4-FFF2-40B4-BE49-F238E27FC236}">
-                <a16:creationId xmlns:a16="http://schemas.microsoft.com/office/drawing/2014/main" id="{4D126E53-CFD2-C027-AA2C-E55710C393E6}"/>
-              </a:ext>
-            </a:extLst>
-          </p:cNvPr>
-          <p:cNvSpPr>
-            <a:spLocks noGrp="1"/>
-          </p:cNvSpPr>
-          <p:nvPr>
-            <p:ph type="sldNum" sz="quarter" idx="12"/>
-          </p:nvPr>
-        </p:nvSpPr>
-        <p:spPr/>
-        <p:txBody>
-          <a:bodyPr/>
-          <a:lstStyle/>
-          <a:p>
-            <a:fld id="{6CC2E120-88CB-4223-BF42-F8F7A034DB50}" type="slidenum">
-              <a:rPr lang="en-US" smtClean="0"/>
-              <a:t>5</a:t>
-            </a:fld>
-            <a:endParaRPr lang="en-US"/>
-          </a:p>
-        </p:txBody>
-      </p:sp>
-    </p:spTree>
-    <p:extLst>
-      <p:ext uri="{BB962C8B-B14F-4D97-AF65-F5344CB8AC3E}">
-        <p14:creationId xmlns:p14="http://schemas.microsoft.com/office/powerpoint/2010/main" val="606434410"/>
-      </p:ext>
-    </p:extLst>
-  </p:cSld>
-  <p:clrMapOvr>
-    <a:masterClrMapping/>
-  </p:clrMapOvr>
-</p:sld>
-</file>
-
-<file path=ppt/slides/slide6.xml><?xml version="1.0" encoding="utf-8"?>
-<p:sld xmlns:a="http://schemas.openxmlformats.org/drawingml/2006/main" xmlns:r="http://schemas.openxmlformats.org/officeDocument/2006/relationships" xmlns:p="http://schemas.openxmlformats.org/presentationml/2006/main">
-  <p:cSld>
-    <p:bg>
-      <p:bgPr>
         <a:solidFill>
           <a:schemeClr val="bg1"/>
         </a:solidFill>
@@ -10716,11 +9760,24 @@
             </a:r>
           </a:p>
           <a:p>
-            <a:pPr indent="-228600" algn="l">
+            <a:pPr marL="342900" indent="-228600" algn="l">
               <a:buFont typeface="Arial" panose="020B0604020202020204" pitchFamily="34" charset="0"/>
               <a:buChar char="•"/>
             </a:pPr>
-            <a:endParaRPr lang="en-US" dirty="0"/>
+            <a:r>
+              <a:rPr lang="en-US" dirty="0"/>
+              <a:t>Estimated Production for 100 users/month</a:t>
+            </a:r>
+          </a:p>
+          <a:p>
+            <a:pPr marL="800100" lvl="1" indent="-228600" algn="l">
+              <a:buFont typeface="Arial" panose="020B0604020202020204" pitchFamily="34" charset="0"/>
+              <a:buChar char="•"/>
+            </a:pPr>
+            <a:r>
+              <a:rPr lang="en-US" dirty="0"/>
+              <a:t>$55 – $89</a:t>
+            </a:r>
           </a:p>
         </p:txBody>
       </p:sp>
@@ -10770,7 +9827,7 @@
                   <a:spcPts val="600"/>
                 </a:spcAft>
               </a:pPr>
-              <a:t>6</a:t>
+              <a:t>5</a:t>
             </a:fld>
             <a:endParaRPr lang="en-US">
               <a:solidFill>
@@ -10795,7 +9852,7 @@
 </p:sld>
 </file>
 
-<file path=ppt/slides/slide7.xml><?xml version="1.0" encoding="utf-8"?>
+<file path=ppt/slides/slide6.xml><?xml version="1.0" encoding="utf-8"?>
 <p:sld xmlns:a="http://schemas.openxmlformats.org/drawingml/2006/main" xmlns:r="http://schemas.openxmlformats.org/officeDocument/2006/relationships" xmlns:p="http://schemas.openxmlformats.org/presentationml/2006/main">
   <p:cSld>
     <p:spTree>
@@ -11025,7 +10082,7 @@
           <a:p>
             <a:fld id="{6CC2E120-88CB-4223-BF42-F8F7A034DB50}" type="slidenum">
               <a:rPr lang="en-US" smtClean="0"/>
-              <a:t>7</a:t>
+              <a:t>6</a:t>
             </a:fld>
             <a:endParaRPr lang="en-US"/>
           </a:p>

</xml_diff>